<commit_message>
added avl rotation example in week 9 slides
</commit_message>
<xml_diff>
--- a/Week9/Week9_Slides.pptx
+++ b/Week9/Week9_Slides.pptx
@@ -12,13 +12,14 @@
     <p:sldId id="272" r:id="rId6"/>
     <p:sldId id="273" r:id="rId7"/>
     <p:sldId id="274" r:id="rId8"/>
-    <p:sldId id="275" r:id="rId9"/>
-    <p:sldId id="276" r:id="rId10"/>
-    <p:sldId id="277" r:id="rId11"/>
-    <p:sldId id="278" r:id="rId12"/>
-    <p:sldId id="279" r:id="rId13"/>
-    <p:sldId id="280" r:id="rId14"/>
-    <p:sldId id="269" r:id="rId15"/>
+    <p:sldId id="281" r:id="rId9"/>
+    <p:sldId id="275" r:id="rId10"/>
+    <p:sldId id="276" r:id="rId11"/>
+    <p:sldId id="277" r:id="rId12"/>
+    <p:sldId id="278" r:id="rId13"/>
+    <p:sldId id="279" r:id="rId14"/>
+    <p:sldId id="280" r:id="rId15"/>
+    <p:sldId id="269" r:id="rId16"/>
   </p:sldIdLst>
   <p:sldSz cx="12192000" cy="6858000"/>
   <p:notesSz cx="6858000" cy="9144000"/>
@@ -311,7 +312,7 @@
           <a:p>
             <a:fld id="{8322A558-B964-4799-A94A-632D1601F177}" type="datetimeFigureOut">
               <a:rPr lang="en-IN" smtClean="0"/>
-              <a:t>18-07-2025</a:t>
+              <a:t>29-07-2025</a:t>
             </a:fld>
             <a:endParaRPr lang="en-IN"/>
           </a:p>
@@ -586,7 +587,7 @@
           <a:p>
             <a:fld id="{8322A558-B964-4799-A94A-632D1601F177}" type="datetimeFigureOut">
               <a:rPr lang="en-IN" smtClean="0"/>
-              <a:t>18-07-2025</a:t>
+              <a:t>29-07-2025</a:t>
             </a:fld>
             <a:endParaRPr lang="en-IN"/>
           </a:p>
@@ -780,7 +781,7 @@
           <a:p>
             <a:fld id="{8322A558-B964-4799-A94A-632D1601F177}" type="datetimeFigureOut">
               <a:rPr lang="en-IN" smtClean="0"/>
-              <a:t>18-07-2025</a:t>
+              <a:t>29-07-2025</a:t>
             </a:fld>
             <a:endParaRPr lang="en-IN"/>
           </a:p>
@@ -1053,7 +1054,7 @@
           <a:p>
             <a:fld id="{8322A558-B964-4799-A94A-632D1601F177}" type="datetimeFigureOut">
               <a:rPr lang="en-IN" smtClean="0"/>
-              <a:t>18-07-2025</a:t>
+              <a:t>29-07-2025</a:t>
             </a:fld>
             <a:endParaRPr lang="en-IN"/>
           </a:p>
@@ -1394,7 +1395,7 @@
           <a:p>
             <a:fld id="{8322A558-B964-4799-A94A-632D1601F177}" type="datetimeFigureOut">
               <a:rPr lang="en-IN" smtClean="0"/>
-              <a:t>18-07-2025</a:t>
+              <a:t>29-07-2025</a:t>
             </a:fld>
             <a:endParaRPr lang="en-IN"/>
           </a:p>
@@ -2017,7 +2018,7 @@
           <a:p>
             <a:fld id="{8322A558-B964-4799-A94A-632D1601F177}" type="datetimeFigureOut">
               <a:rPr lang="en-IN" smtClean="0"/>
-              <a:t>18-07-2025</a:t>
+              <a:t>29-07-2025</a:t>
             </a:fld>
             <a:endParaRPr lang="en-IN"/>
           </a:p>
@@ -2877,7 +2878,7 @@
           <a:p>
             <a:fld id="{8322A558-B964-4799-A94A-632D1601F177}" type="datetimeFigureOut">
               <a:rPr lang="en-IN" smtClean="0"/>
-              <a:t>18-07-2025</a:t>
+              <a:t>29-07-2025</a:t>
             </a:fld>
             <a:endParaRPr lang="en-IN"/>
           </a:p>
@@ -3047,7 +3048,7 @@
           <a:p>
             <a:fld id="{8322A558-B964-4799-A94A-632D1601F177}" type="datetimeFigureOut">
               <a:rPr lang="en-IN" smtClean="0"/>
-              <a:t>18-07-2025</a:t>
+              <a:t>29-07-2025</a:t>
             </a:fld>
             <a:endParaRPr lang="en-IN"/>
           </a:p>
@@ -3227,7 +3228,7 @@
           <a:p>
             <a:fld id="{8322A558-B964-4799-A94A-632D1601F177}" type="datetimeFigureOut">
               <a:rPr lang="en-IN" smtClean="0"/>
-              <a:t>18-07-2025</a:t>
+              <a:t>29-07-2025</a:t>
             </a:fld>
             <a:endParaRPr lang="en-IN"/>
           </a:p>
@@ -3397,7 +3398,7 @@
           <a:p>
             <a:fld id="{8322A558-B964-4799-A94A-632D1601F177}" type="datetimeFigureOut">
               <a:rPr lang="en-IN" smtClean="0"/>
-              <a:t>18-07-2025</a:t>
+              <a:t>29-07-2025</a:t>
             </a:fld>
             <a:endParaRPr lang="en-IN"/>
           </a:p>
@@ -3644,7 +3645,7 @@
           <a:p>
             <a:fld id="{8322A558-B964-4799-A94A-632D1601F177}" type="datetimeFigureOut">
               <a:rPr lang="en-IN" smtClean="0"/>
-              <a:t>18-07-2025</a:t>
+              <a:t>29-07-2025</a:t>
             </a:fld>
             <a:endParaRPr lang="en-IN"/>
           </a:p>
@@ -3936,7 +3937,7 @@
           <a:p>
             <a:fld id="{8322A558-B964-4799-A94A-632D1601F177}" type="datetimeFigureOut">
               <a:rPr lang="en-IN" smtClean="0"/>
-              <a:t>18-07-2025</a:t>
+              <a:t>29-07-2025</a:t>
             </a:fld>
             <a:endParaRPr lang="en-IN"/>
           </a:p>
@@ -4380,7 +4381,7 @@
           <a:p>
             <a:fld id="{8322A558-B964-4799-A94A-632D1601F177}" type="datetimeFigureOut">
               <a:rPr lang="en-IN" smtClean="0"/>
-              <a:t>18-07-2025</a:t>
+              <a:t>29-07-2025</a:t>
             </a:fld>
             <a:endParaRPr lang="en-IN"/>
           </a:p>
@@ -4498,7 +4499,7 @@
           <a:p>
             <a:fld id="{8322A558-B964-4799-A94A-632D1601F177}" type="datetimeFigureOut">
               <a:rPr lang="en-IN" smtClean="0"/>
-              <a:t>18-07-2025</a:t>
+              <a:t>29-07-2025</a:t>
             </a:fld>
             <a:endParaRPr lang="en-IN"/>
           </a:p>
@@ -4593,7 +4594,7 @@
           <a:p>
             <a:fld id="{8322A558-B964-4799-A94A-632D1601F177}" type="datetimeFigureOut">
               <a:rPr lang="en-IN" smtClean="0"/>
-              <a:t>18-07-2025</a:t>
+              <a:t>29-07-2025</a:t>
             </a:fld>
             <a:endParaRPr lang="en-IN"/>
           </a:p>
@@ -4872,7 +4873,7 @@
           <a:p>
             <a:fld id="{8322A558-B964-4799-A94A-632D1601F177}" type="datetimeFigureOut">
               <a:rPr lang="en-IN" smtClean="0"/>
-              <a:t>18-07-2025</a:t>
+              <a:t>29-07-2025</a:t>
             </a:fld>
             <a:endParaRPr lang="en-IN"/>
           </a:p>
@@ -5147,7 +5148,7 @@
           <a:p>
             <a:fld id="{8322A558-B964-4799-A94A-632D1601F177}" type="datetimeFigureOut">
               <a:rPr lang="en-IN" smtClean="0"/>
-              <a:t>18-07-2025</a:t>
+              <a:t>29-07-2025</a:t>
             </a:fld>
             <a:endParaRPr lang="en-IN"/>
           </a:p>
@@ -5576,7 +5577,7 @@
           <a:p>
             <a:fld id="{8322A558-B964-4799-A94A-632D1601F177}" type="datetimeFigureOut">
               <a:rPr lang="en-IN" smtClean="0"/>
-              <a:t>18-07-2025</a:t>
+              <a:t>29-07-2025</a:t>
             </a:fld>
             <a:endParaRPr lang="en-IN"/>
           </a:p>
@@ -6240,6 +6241,368 @@
           <p:cNvPr id="2" name="Title 1">
             <a:extLst>
               <a:ext uri="{FF2B5EF4-FFF2-40B4-BE49-F238E27FC236}">
+                <a16:creationId xmlns:a16="http://schemas.microsoft.com/office/drawing/2014/main" id="{EF58C4EA-0BAE-9711-10A3-0090DA183A36}"/>
+              </a:ext>
+            </a:extLst>
+          </p:cNvPr>
+          <p:cNvSpPr>
+            <a:spLocks noGrp="1"/>
+          </p:cNvSpPr>
+          <p:nvPr>
+            <p:ph type="title"/>
+          </p:nvPr>
+        </p:nvSpPr>
+        <p:spPr/>
+        <p:txBody>
+          <a:bodyPr/>
+          <a:lstStyle/>
+          <a:p>
+            <a:r>
+              <a:rPr lang="en-IN" b="1" dirty="0"/>
+              <a:t>Heap – Deep Dive Theory</a:t>
+            </a:r>
+            <a:br>
+              <a:rPr lang="en-IN" b="1" dirty="0"/>
+            </a:br>
+            <a:endParaRPr lang="en-IN" b="1" dirty="0"/>
+          </a:p>
+        </p:txBody>
+      </p:sp>
+      <mc:AlternateContent xmlns:mc="http://schemas.openxmlformats.org/markup-compatibility/2006" xmlns:a14="http://schemas.microsoft.com/office/drawing/2010/main">
+        <mc:Choice Requires="a14">
+          <p:sp>
+            <p:nvSpPr>
+              <p:cNvPr id="3" name="Content Placeholder 2">
+                <a:extLst>
+                  <a:ext uri="{FF2B5EF4-FFF2-40B4-BE49-F238E27FC236}">
+                    <a16:creationId xmlns:a16="http://schemas.microsoft.com/office/drawing/2014/main" id="{FAD27265-03E3-2FE1-D251-028B8CD870F5}"/>
+                  </a:ext>
+                </a:extLst>
+              </p:cNvPr>
+              <p:cNvSpPr>
+                <a:spLocks noGrp="1"/>
+              </p:cNvSpPr>
+              <p:nvPr>
+                <p:ph idx="1"/>
+              </p:nvPr>
+            </p:nvSpPr>
+            <p:spPr/>
+            <p:txBody>
+              <a:bodyPr/>
+              <a:lstStyle/>
+              <a:p>
+                <a:r>
+                  <a:rPr lang="en-IN" dirty="0"/>
+                  <a:t>Insert(x): </a:t>
+                </a:r>
+                <a:r>
+                  <a:rPr lang="en-US" dirty="0"/>
+                  <a:t>Place x at end of array, "bubble up" to maintain heap → O(log n).</a:t>
+                </a:r>
+              </a:p>
+              <a:p>
+                <a:r>
+                  <a:rPr lang="en-IN" dirty="0"/>
+                  <a:t>Extract-Min/Max(): </a:t>
+                </a:r>
+                <a:r>
+                  <a:rPr lang="en-US" dirty="0"/>
+                  <a:t>Remove root, replace with last element, "bubble down" → O(log n).</a:t>
+                </a:r>
+              </a:p>
+              <a:p>
+                <a:r>
+                  <a:rPr lang="en-IN" dirty="0"/>
+                  <a:t>Build-Heap(A):</a:t>
+                </a:r>
+              </a:p>
+              <a:p>
+                <a:pPr lvl="1"/>
+                <a:r>
+                  <a:rPr lang="en-US" dirty="0"/>
+                  <a:t>Convert unordered array into a heap → O(n).</a:t>
+                </a:r>
+              </a:p>
+              <a:p>
+                <a:pPr lvl="1"/>
+                <a:r>
+                  <a:rPr lang="en-IN" dirty="0"/>
+                  <a:t>Done using bottom-up </a:t>
+                </a:r>
+                <a:r>
+                  <a:rPr lang="en-IN" dirty="0" err="1"/>
+                  <a:t>heapify</a:t>
+                </a:r>
+                <a:r>
+                  <a:rPr lang="en-IN" dirty="0"/>
+                  <a:t>:</a:t>
+                </a:r>
+              </a:p>
+              <a:p>
+                <a:pPr lvl="2"/>
+                <a14:m>
+                  <m:oMath xmlns:m="http://schemas.openxmlformats.org/officeDocument/2006/math">
+                    <m:r>
+                      <a:rPr lang="en-IN" i="1" smtClean="0">
+                        <a:latin typeface="Cambria Math" panose="02040503050406030204" pitchFamily="18" charset="0"/>
+                      </a:rPr>
+                      <m:t>𝑇</m:t>
+                    </m:r>
+                    <m:d>
+                      <m:dPr>
+                        <m:ctrlPr>
+                          <a:rPr lang="en-IN" i="1" smtClean="0">
+                            <a:solidFill>
+                              <a:srgbClr val="836967"/>
+                            </a:solidFill>
+                            <a:latin typeface="Cambria Math" panose="02040503050406030204" pitchFamily="18" charset="0"/>
+                          </a:rPr>
+                        </m:ctrlPr>
+                      </m:dPr>
+                      <m:e>
+                        <m:r>
+                          <a:rPr lang="en-IN" i="1" smtClean="0">
+                            <a:latin typeface="Cambria Math" panose="02040503050406030204" pitchFamily="18" charset="0"/>
+                          </a:rPr>
+                          <m:t>𝑁</m:t>
+                        </m:r>
+                      </m:e>
+                    </m:d>
+                    <m:r>
+                      <a:rPr lang="en-IN" i="1" smtClean="0">
+                        <a:latin typeface="Cambria Math" panose="02040503050406030204" pitchFamily="18" charset="0"/>
+                      </a:rPr>
+                      <m:t>=</m:t>
+                    </m:r>
+                    <m:nary>
+                      <m:naryPr>
+                        <m:chr m:val="∑"/>
+                        <m:limLoc m:val="undOvr"/>
+                        <m:grow m:val="on"/>
+                        <m:ctrlPr>
+                          <a:rPr lang="en-IN" i="1" smtClean="0">
+                            <a:latin typeface="Cambria Math" panose="02040503050406030204" pitchFamily="18" charset="0"/>
+                          </a:rPr>
+                        </m:ctrlPr>
+                      </m:naryPr>
+                      <m:sub>
+                        <m:r>
+                          <a:rPr lang="en-IN" i="1" smtClean="0">
+                            <a:latin typeface="Cambria Math" panose="02040503050406030204" pitchFamily="18" charset="0"/>
+                          </a:rPr>
+                          <m:t>𝑖</m:t>
+                        </m:r>
+                        <m:r>
+                          <a:rPr lang="en-IN" i="1" smtClean="0">
+                            <a:latin typeface="Cambria Math" panose="02040503050406030204" pitchFamily="18" charset="0"/>
+                          </a:rPr>
+                          <m:t>=1</m:t>
+                        </m:r>
+                      </m:sub>
+                      <m:sup>
+                        <m:func>
+                          <m:funcPr>
+                            <m:ctrlPr>
+                              <a:rPr lang="en-IN" i="1" smtClean="0">
+                                <a:latin typeface="Cambria Math" panose="02040503050406030204" pitchFamily="18" charset="0"/>
+                              </a:rPr>
+                            </m:ctrlPr>
+                          </m:funcPr>
+                          <m:fName>
+                            <m:r>
+                              <m:rPr>
+                                <m:sty m:val="p"/>
+                              </m:rPr>
+                              <a:rPr lang="en-IN" i="1" smtClean="0">
+                                <a:latin typeface="Cambria Math" panose="02040503050406030204" pitchFamily="18" charset="0"/>
+                              </a:rPr>
+                              <m:t>log</m:t>
+                            </m:r>
+                          </m:fName>
+                          <m:e>
+                            <m:r>
+                              <a:rPr lang="en-IN" i="1" smtClean="0">
+                                <a:latin typeface="Cambria Math" panose="02040503050406030204" pitchFamily="18" charset="0"/>
+                              </a:rPr>
+                              <m:t>𝑁</m:t>
+                            </m:r>
+                          </m:e>
+                        </m:func>
+                      </m:sup>
+                      <m:e>
+                        <m:f>
+                          <m:fPr>
+                            <m:ctrlPr>
+                              <a:rPr lang="en-IN" i="1" smtClean="0">
+                                <a:solidFill>
+                                  <a:srgbClr val="836967"/>
+                                </a:solidFill>
+                                <a:latin typeface="Cambria Math" panose="02040503050406030204" pitchFamily="18" charset="0"/>
+                              </a:rPr>
+                            </m:ctrlPr>
+                          </m:fPr>
+                          <m:num>
+                            <m:r>
+                              <a:rPr lang="en-IN" i="1" smtClean="0">
+                                <a:latin typeface="Cambria Math" panose="02040503050406030204" pitchFamily="18" charset="0"/>
+                              </a:rPr>
+                              <m:t>𝑁</m:t>
+                            </m:r>
+                          </m:num>
+                          <m:den>
+                            <m:sSup>
+                              <m:sSupPr>
+                                <m:ctrlPr>
+                                  <a:rPr lang="en-IN" i="1" smtClean="0">
+                                    <a:solidFill>
+                                      <a:srgbClr val="836967"/>
+                                    </a:solidFill>
+                                    <a:latin typeface="Cambria Math" panose="02040503050406030204" pitchFamily="18" charset="0"/>
+                                  </a:rPr>
+                                </m:ctrlPr>
+                              </m:sSupPr>
+                              <m:e>
+                                <m:r>
+                                  <a:rPr lang="en-IN" i="1" smtClean="0">
+                                    <a:latin typeface="Cambria Math" panose="02040503050406030204" pitchFamily="18" charset="0"/>
+                                  </a:rPr>
+                                  <m:t>2</m:t>
+                                </m:r>
+                              </m:e>
+                              <m:sup>
+                                <m:r>
+                                  <a:rPr lang="en-IN" i="1" smtClean="0">
+                                    <a:latin typeface="Cambria Math" panose="02040503050406030204" pitchFamily="18" charset="0"/>
+                                  </a:rPr>
+                                  <m:t>𝑖</m:t>
+                                </m:r>
+                              </m:sup>
+                            </m:sSup>
+                          </m:den>
+                        </m:f>
+                      </m:e>
+                    </m:nary>
+                    <m:r>
+                      <a:rPr lang="en-IN" i="1" smtClean="0">
+                        <a:latin typeface="Cambria Math" panose="02040503050406030204" pitchFamily="18" charset="0"/>
+                      </a:rPr>
+                      <m:t>⋅ⅈ=</m:t>
+                    </m:r>
+                    <m:r>
+                      <a:rPr lang="en-IN" b="0" i="1" smtClean="0">
+                        <a:latin typeface="Cambria Math" panose="02040503050406030204" pitchFamily="18" charset="0"/>
+                      </a:rPr>
+                      <m:t>𝑂</m:t>
+                    </m:r>
+                    <m:d>
+                      <m:dPr>
+                        <m:ctrlPr>
+                          <a:rPr lang="en-IN" i="1" smtClean="0">
+                            <a:solidFill>
+                              <a:srgbClr val="836967"/>
+                            </a:solidFill>
+                            <a:latin typeface="Cambria Math" panose="02040503050406030204" pitchFamily="18" charset="0"/>
+                          </a:rPr>
+                        </m:ctrlPr>
+                      </m:dPr>
+                      <m:e>
+                        <m:r>
+                          <a:rPr lang="en-IN" i="1" smtClean="0">
+                            <a:latin typeface="Cambria Math" panose="02040503050406030204" pitchFamily="18" charset="0"/>
+                          </a:rPr>
+                          <m:t>𝑁</m:t>
+                        </m:r>
+                      </m:e>
+                    </m:d>
+                  </m:oMath>
+                </a14:m>
+                <a:endParaRPr lang="en-IN" dirty="0"/>
+              </a:p>
+              <a:p>
+                <a:r>
+                  <a:rPr lang="en-US" dirty="0"/>
+                  <a:t>Heap is not BST: No search guarantees or in-order traversal.</a:t>
+                </a:r>
+                <a:endParaRPr lang="en-IN" dirty="0"/>
+              </a:p>
+            </p:txBody>
+          </p:sp>
+        </mc:Choice>
+        <mc:Fallback xmlns="">
+          <p:sp>
+            <p:nvSpPr>
+              <p:cNvPr id="3" name="Content Placeholder 2">
+                <a:extLst>
+                  <a:ext uri="{FF2B5EF4-FFF2-40B4-BE49-F238E27FC236}">
+                    <a16:creationId xmlns:a16="http://schemas.microsoft.com/office/drawing/2014/main" id="{FAD27265-03E3-2FE1-D251-028B8CD870F5}"/>
+                  </a:ext>
+                </a:extLst>
+              </p:cNvPr>
+              <p:cNvSpPr>
+                <a:spLocks noGrp="1" noRot="1" noChangeAspect="1" noMove="1" noResize="1" noEditPoints="1" noAdjustHandles="1" noChangeArrowheads="1" noChangeShapeType="1" noTextEdit="1"/>
+              </p:cNvSpPr>
+              <p:nvPr>
+                <p:ph idx="1"/>
+              </p:nvPr>
+            </p:nvSpPr>
+            <p:spPr>
+              <a:blipFill>
+                <a:blip r:embed="rId2"/>
+                <a:stretch>
+                  <a:fillRect l="-341" t="-872"/>
+                </a:stretch>
+              </a:blipFill>
+            </p:spPr>
+            <p:txBody>
+              <a:bodyPr/>
+              <a:lstStyle/>
+              <a:p>
+                <a:r>
+                  <a:rPr lang="en-IN">
+                    <a:noFill/>
+                  </a:rPr>
+                  <a:t> </a:t>
+                </a:r>
+              </a:p>
+            </p:txBody>
+          </p:sp>
+        </mc:Fallback>
+      </mc:AlternateContent>
+    </p:spTree>
+    <p:extLst>
+      <p:ext uri="{BB962C8B-B14F-4D97-AF65-F5344CB8AC3E}">
+        <p14:creationId xmlns:p14="http://schemas.microsoft.com/office/powerpoint/2010/main" val="4014647038"/>
+      </p:ext>
+    </p:extLst>
+  </p:cSld>
+  <p:clrMapOvr>
+    <a:masterClrMapping/>
+  </p:clrMapOvr>
+</p:sld>
+</file>
+
+<file path=ppt/slides/slide11.xml><?xml version="1.0" encoding="utf-8"?>
+<p:sld xmlns:a="http://schemas.openxmlformats.org/drawingml/2006/main" xmlns:r="http://schemas.openxmlformats.org/officeDocument/2006/relationships" xmlns:p="http://schemas.openxmlformats.org/presentationml/2006/main">
+  <p:cSld>
+    <p:spTree>
+      <p:nvGrpSpPr>
+        <p:cNvPr id="1" name=""/>
+        <p:cNvGrpSpPr/>
+        <p:nvPr/>
+      </p:nvGrpSpPr>
+      <p:grpSpPr>
+        <a:xfrm>
+          <a:off x="0" y="0"/>
+          <a:ext cx="0" cy="0"/>
+          <a:chOff x="0" y="0"/>
+          <a:chExt cx="0" cy="0"/>
+        </a:xfrm>
+      </p:grpSpPr>
+      <p:sp>
+        <p:nvSpPr>
+          <p:cNvPr id="2" name="Title 1">
+            <a:extLst>
+              <a:ext uri="{FF2B5EF4-FFF2-40B4-BE49-F238E27FC236}">
                 <a16:creationId xmlns:a16="http://schemas.microsoft.com/office/drawing/2014/main" id="{26939138-A464-D250-5C24-95D417658626}"/>
               </a:ext>
             </a:extLst>
@@ -6362,7 +6725,7 @@
 </p:sld>
 </file>
 
-<file path=ppt/slides/slide11.xml><?xml version="1.0" encoding="utf-8"?>
+<file path=ppt/slides/slide12.xml><?xml version="1.0" encoding="utf-8"?>
 <p:sld xmlns:a="http://schemas.openxmlformats.org/drawingml/2006/main" xmlns:r="http://schemas.openxmlformats.org/officeDocument/2006/relationships" xmlns:p="http://schemas.openxmlformats.org/presentationml/2006/main">
   <p:cSld>
     <p:spTree>
@@ -6905,154 +7268,6 @@
 </p:sld>
 </file>
 
-<file path=ppt/slides/slide12.xml><?xml version="1.0" encoding="utf-8"?>
-<p:sld xmlns:a="http://schemas.openxmlformats.org/drawingml/2006/main" xmlns:r="http://schemas.openxmlformats.org/officeDocument/2006/relationships" xmlns:p="http://schemas.openxmlformats.org/presentationml/2006/main">
-  <p:cSld>
-    <p:spTree>
-      <p:nvGrpSpPr>
-        <p:cNvPr id="1" name=""/>
-        <p:cNvGrpSpPr/>
-        <p:nvPr/>
-      </p:nvGrpSpPr>
-      <p:grpSpPr>
-        <a:xfrm>
-          <a:off x="0" y="0"/>
-          <a:ext cx="0" cy="0"/>
-          <a:chOff x="0" y="0"/>
-          <a:chExt cx="0" cy="0"/>
-        </a:xfrm>
-      </p:grpSpPr>
-      <p:sp>
-        <p:nvSpPr>
-          <p:cNvPr id="2" name="Title 1">
-            <a:extLst>
-              <a:ext uri="{FF2B5EF4-FFF2-40B4-BE49-F238E27FC236}">
-                <a16:creationId xmlns:a16="http://schemas.microsoft.com/office/drawing/2014/main" id="{FC9C93A7-CA95-63E4-89F5-56E2321CF5CD}"/>
-              </a:ext>
-            </a:extLst>
-          </p:cNvPr>
-          <p:cNvSpPr>
-            <a:spLocks noGrp="1"/>
-          </p:cNvSpPr>
-          <p:nvPr>
-            <p:ph type="title"/>
-          </p:nvPr>
-        </p:nvSpPr>
-        <p:spPr/>
-        <p:txBody>
-          <a:bodyPr/>
-          <a:lstStyle/>
-          <a:p>
-            <a:r>
-              <a:rPr lang="en-IN" b="1" dirty="0"/>
-              <a:t>Applications and Use Cases</a:t>
-            </a:r>
-          </a:p>
-        </p:txBody>
-      </p:sp>
-      <p:sp>
-        <p:nvSpPr>
-          <p:cNvPr id="3" name="Content Placeholder 2">
-            <a:extLst>
-              <a:ext uri="{FF2B5EF4-FFF2-40B4-BE49-F238E27FC236}">
-                <a16:creationId xmlns:a16="http://schemas.microsoft.com/office/drawing/2014/main" id="{43282D1F-59B3-612B-30AE-CAF2990BEF84}"/>
-              </a:ext>
-            </a:extLst>
-          </p:cNvPr>
-          <p:cNvSpPr>
-            <a:spLocks noGrp="1"/>
-          </p:cNvSpPr>
-          <p:nvPr>
-            <p:ph idx="1"/>
-          </p:nvPr>
-        </p:nvSpPr>
-        <p:spPr/>
-        <p:txBody>
-          <a:bodyPr/>
-          <a:lstStyle/>
-          <a:p>
-            <a:r>
-              <a:rPr lang="en-IN" dirty="0"/>
-              <a:t>Binary Search Tree (BST)</a:t>
-            </a:r>
-          </a:p>
-          <a:p>
-            <a:pPr lvl="1"/>
-            <a:r>
-              <a:rPr lang="en-US" dirty="0"/>
-              <a:t>Search trees, sets/maps, memory indexing</a:t>
-            </a:r>
-            <a:endParaRPr lang="en-IN" dirty="0"/>
-          </a:p>
-          <a:p>
-            <a:r>
-              <a:rPr lang="en-IN" dirty="0"/>
-              <a:t>AVL Trees</a:t>
-            </a:r>
-          </a:p>
-          <a:p>
-            <a:pPr lvl="1"/>
-            <a:r>
-              <a:rPr lang="en-US" dirty="0"/>
-              <a:t>High-speed lookup where insert/delete is rare</a:t>
-            </a:r>
-          </a:p>
-          <a:p>
-            <a:pPr lvl="1"/>
-            <a:r>
-              <a:rPr lang="en-IN" dirty="0"/>
-              <a:t>Databases, language compilers</a:t>
-            </a:r>
-          </a:p>
-          <a:p>
-            <a:r>
-              <a:rPr lang="en-IN" dirty="0"/>
-              <a:t>Heaps/Priority Queues</a:t>
-            </a:r>
-          </a:p>
-          <a:p>
-            <a:pPr lvl="1"/>
-            <a:r>
-              <a:rPr lang="en-IN" dirty="0"/>
-              <a:t>Operating system schedulers</a:t>
-            </a:r>
-          </a:p>
-          <a:p>
-            <a:pPr lvl="1"/>
-            <a:r>
-              <a:rPr lang="en-IN" dirty="0"/>
-              <a:t>Event-driven simulations</a:t>
-            </a:r>
-          </a:p>
-          <a:p>
-            <a:pPr lvl="1"/>
-            <a:r>
-              <a:rPr lang="en-US" dirty="0"/>
-              <a:t>Dijkstra’s &amp; Prim’s algorithms (graph problems)</a:t>
-            </a:r>
-          </a:p>
-          <a:p>
-            <a:pPr lvl="1"/>
-            <a:r>
-              <a:rPr lang="en-IN" dirty="0"/>
-              <a:t>Huffman encoding for compression</a:t>
-            </a:r>
-          </a:p>
-        </p:txBody>
-      </p:sp>
-    </p:spTree>
-    <p:extLst>
-      <p:ext uri="{BB962C8B-B14F-4D97-AF65-F5344CB8AC3E}">
-        <p14:creationId xmlns:p14="http://schemas.microsoft.com/office/powerpoint/2010/main" val="2492061472"/>
-      </p:ext>
-    </p:extLst>
-  </p:cSld>
-  <p:clrMapOvr>
-    <a:masterClrMapping/>
-  </p:clrMapOvr>
-</p:sld>
-</file>
-
 <file path=ppt/slides/slide13.xml><?xml version="1.0" encoding="utf-8"?>
 <p:sld xmlns:a="http://schemas.openxmlformats.org/drawingml/2006/main" xmlns:r="http://schemas.openxmlformats.org/officeDocument/2006/relationships" xmlns:p="http://schemas.openxmlformats.org/presentationml/2006/main">
   <p:cSld>
@@ -7075,6 +7290,154 @@
           <p:cNvPr id="2" name="Title 1">
             <a:extLst>
               <a:ext uri="{FF2B5EF4-FFF2-40B4-BE49-F238E27FC236}">
+                <a16:creationId xmlns:a16="http://schemas.microsoft.com/office/drawing/2014/main" id="{FC9C93A7-CA95-63E4-89F5-56E2321CF5CD}"/>
+              </a:ext>
+            </a:extLst>
+          </p:cNvPr>
+          <p:cNvSpPr>
+            <a:spLocks noGrp="1"/>
+          </p:cNvSpPr>
+          <p:nvPr>
+            <p:ph type="title"/>
+          </p:nvPr>
+        </p:nvSpPr>
+        <p:spPr/>
+        <p:txBody>
+          <a:bodyPr/>
+          <a:lstStyle/>
+          <a:p>
+            <a:r>
+              <a:rPr lang="en-IN" b="1" dirty="0"/>
+              <a:t>Applications and Use Cases</a:t>
+            </a:r>
+          </a:p>
+        </p:txBody>
+      </p:sp>
+      <p:sp>
+        <p:nvSpPr>
+          <p:cNvPr id="3" name="Content Placeholder 2">
+            <a:extLst>
+              <a:ext uri="{FF2B5EF4-FFF2-40B4-BE49-F238E27FC236}">
+                <a16:creationId xmlns:a16="http://schemas.microsoft.com/office/drawing/2014/main" id="{43282D1F-59B3-612B-30AE-CAF2990BEF84}"/>
+              </a:ext>
+            </a:extLst>
+          </p:cNvPr>
+          <p:cNvSpPr>
+            <a:spLocks noGrp="1"/>
+          </p:cNvSpPr>
+          <p:nvPr>
+            <p:ph idx="1"/>
+          </p:nvPr>
+        </p:nvSpPr>
+        <p:spPr/>
+        <p:txBody>
+          <a:bodyPr/>
+          <a:lstStyle/>
+          <a:p>
+            <a:r>
+              <a:rPr lang="en-IN" dirty="0"/>
+              <a:t>Binary Search Tree (BST)</a:t>
+            </a:r>
+          </a:p>
+          <a:p>
+            <a:pPr lvl="1"/>
+            <a:r>
+              <a:rPr lang="en-US" dirty="0"/>
+              <a:t>Search trees, sets/maps, memory indexing</a:t>
+            </a:r>
+            <a:endParaRPr lang="en-IN" dirty="0"/>
+          </a:p>
+          <a:p>
+            <a:r>
+              <a:rPr lang="en-IN" dirty="0"/>
+              <a:t>AVL Trees</a:t>
+            </a:r>
+          </a:p>
+          <a:p>
+            <a:pPr lvl="1"/>
+            <a:r>
+              <a:rPr lang="en-US" dirty="0"/>
+              <a:t>High-speed lookup where insert/delete is rare</a:t>
+            </a:r>
+          </a:p>
+          <a:p>
+            <a:pPr lvl="1"/>
+            <a:r>
+              <a:rPr lang="en-IN" dirty="0"/>
+              <a:t>Databases, language compilers</a:t>
+            </a:r>
+          </a:p>
+          <a:p>
+            <a:r>
+              <a:rPr lang="en-IN" dirty="0"/>
+              <a:t>Heaps/Priority Queues</a:t>
+            </a:r>
+          </a:p>
+          <a:p>
+            <a:pPr lvl="1"/>
+            <a:r>
+              <a:rPr lang="en-IN" dirty="0"/>
+              <a:t>Operating system schedulers</a:t>
+            </a:r>
+          </a:p>
+          <a:p>
+            <a:pPr lvl="1"/>
+            <a:r>
+              <a:rPr lang="en-IN" dirty="0"/>
+              <a:t>Event-driven simulations</a:t>
+            </a:r>
+          </a:p>
+          <a:p>
+            <a:pPr lvl="1"/>
+            <a:r>
+              <a:rPr lang="en-US" dirty="0"/>
+              <a:t>Dijkstra’s &amp; Prim’s algorithms (graph problems)</a:t>
+            </a:r>
+          </a:p>
+          <a:p>
+            <a:pPr lvl="1"/>
+            <a:r>
+              <a:rPr lang="en-IN" dirty="0"/>
+              <a:t>Huffman encoding for compression</a:t>
+            </a:r>
+          </a:p>
+        </p:txBody>
+      </p:sp>
+    </p:spTree>
+    <p:extLst>
+      <p:ext uri="{BB962C8B-B14F-4D97-AF65-F5344CB8AC3E}">
+        <p14:creationId xmlns:p14="http://schemas.microsoft.com/office/powerpoint/2010/main" val="2492061472"/>
+      </p:ext>
+    </p:extLst>
+  </p:cSld>
+  <p:clrMapOvr>
+    <a:masterClrMapping/>
+  </p:clrMapOvr>
+</p:sld>
+</file>
+
+<file path=ppt/slides/slide14.xml><?xml version="1.0" encoding="utf-8"?>
+<p:sld xmlns:a="http://schemas.openxmlformats.org/drawingml/2006/main" xmlns:r="http://schemas.openxmlformats.org/officeDocument/2006/relationships" xmlns:p="http://schemas.openxmlformats.org/presentationml/2006/main">
+  <p:cSld>
+    <p:spTree>
+      <p:nvGrpSpPr>
+        <p:cNvPr id="1" name=""/>
+        <p:cNvGrpSpPr/>
+        <p:nvPr/>
+      </p:nvGrpSpPr>
+      <p:grpSpPr>
+        <a:xfrm>
+          <a:off x="0" y="0"/>
+          <a:ext cx="0" cy="0"/>
+          <a:chOff x="0" y="0"/>
+          <a:chExt cx="0" cy="0"/>
+        </a:xfrm>
+      </p:grpSpPr>
+      <p:sp>
+        <p:nvSpPr>
+          <p:cNvPr id="2" name="Title 1">
+            <a:extLst>
+              <a:ext uri="{FF2B5EF4-FFF2-40B4-BE49-F238E27FC236}">
                 <a16:creationId xmlns:a16="http://schemas.microsoft.com/office/drawing/2014/main" id="{B49556DA-3BB3-23F5-3069-E71697C3CFF4}"/>
               </a:ext>
             </a:extLst>
@@ -7197,7 +7560,7 @@
 </p:sld>
 </file>
 
-<file path=ppt/slides/slide14.xml><?xml version="1.0" encoding="utf-8"?>
+<file path=ppt/slides/slide15.xml><?xml version="1.0" encoding="utf-8"?>
 <p:sld xmlns:a="http://schemas.openxmlformats.org/drawingml/2006/main" xmlns:r="http://schemas.openxmlformats.org/officeDocument/2006/relationships" xmlns:p="http://schemas.openxmlformats.org/presentationml/2006/main">
   <p:cSld>
     <p:spTree>
@@ -8364,8 +8727,8 @@
           </a:p>
         </p:txBody>
       </p:sp>
-      <mc:AlternateContent xmlns:mc="http://schemas.openxmlformats.org/markup-compatibility/2006">
-        <mc:Choice xmlns:a14="http://schemas.microsoft.com/office/drawing/2010/main" Requires="a14">
+      <mc:AlternateContent xmlns:mc="http://schemas.openxmlformats.org/markup-compatibility/2006" xmlns:a14="http://schemas.microsoft.com/office/drawing/2010/main">
+        <mc:Choice Requires="a14">
           <p:sp>
             <p:nvSpPr>
               <p:cNvPr id="3" name="Content Placeholder 2">
@@ -8558,7 +8921,7 @@
             </p:txBody>
           </p:sp>
         </mc:Choice>
-        <mc:Fallback>
+        <mc:Fallback xmlns="">
           <p:sp>
             <p:nvSpPr>
               <p:cNvPr id="3" name="Content Placeholder 2">
@@ -8633,7 +8996,7 @@
           <p:cNvPr id="2" name="Title 1">
             <a:extLst>
               <a:ext uri="{FF2B5EF4-FFF2-40B4-BE49-F238E27FC236}">
-                <a16:creationId xmlns:a16="http://schemas.microsoft.com/office/drawing/2014/main" id="{4A25E700-863B-5B39-1E7B-FE12B63574C2}"/>
+                <a16:creationId xmlns:a16="http://schemas.microsoft.com/office/drawing/2014/main" id="{7FAEC5B1-3B3E-A0F7-CAD2-0867B4994453}"/>
               </a:ext>
             </a:extLst>
           </p:cNvPr>
@@ -8651,103 +9014,62 @@
           <a:p>
             <a:r>
               <a:rPr lang="en-IN" b="1" dirty="0"/>
-              <a:t>Heap – Concepts</a:t>
-            </a:r>
-            <a:br>
-              <a:rPr lang="en-IN" b="1" dirty="0"/>
-            </a:br>
-            <a:endParaRPr lang="en-IN" b="1" dirty="0"/>
-          </a:p>
-        </p:txBody>
-      </p:sp>
-      <p:sp>
-        <p:nvSpPr>
-          <p:cNvPr id="3" name="Content Placeholder 2">
+              <a:t>AVL – Rotation Example</a:t>
+            </a:r>
+          </a:p>
+        </p:txBody>
+      </p:sp>
+      <p:pic>
+        <p:nvPicPr>
+          <p:cNvPr id="1026" name="Picture 2" descr="AVL Tree Algorithm">
             <a:extLst>
               <a:ext uri="{FF2B5EF4-FFF2-40B4-BE49-F238E27FC236}">
-                <a16:creationId xmlns:a16="http://schemas.microsoft.com/office/drawing/2014/main" id="{F8C21B42-A14A-5CD2-C7F3-3EF26A323FF0}"/>
+                <a16:creationId xmlns:a16="http://schemas.microsoft.com/office/drawing/2014/main" id="{BB1BA476-D332-B7EA-C4E3-E932D0EF4399}"/>
               </a:ext>
             </a:extLst>
           </p:cNvPr>
-          <p:cNvSpPr>
-            <a:spLocks noGrp="1"/>
-          </p:cNvSpPr>
-          <p:nvPr>
-            <p:ph idx="1"/>
-          </p:nvPr>
-        </p:nvSpPr>
-        <p:spPr/>
-        <p:txBody>
-          <a:bodyPr/>
-          <a:lstStyle/>
-          <a:p>
-            <a:r>
-              <a:rPr lang="en-US" dirty="0"/>
-              <a:t>A heap is a binary tree where each node satisfies the heap-order property:</a:t>
-            </a:r>
-          </a:p>
-          <a:p>
-            <a:pPr lvl="1"/>
-            <a:r>
-              <a:rPr lang="en-US" b="1" dirty="0"/>
-              <a:t>Min-Heap</a:t>
-            </a:r>
-            <a:r>
-              <a:rPr lang="en-US" dirty="0"/>
-              <a:t>: key(parent) ≤ key(children)</a:t>
-            </a:r>
-          </a:p>
-          <a:p>
-            <a:pPr lvl="1"/>
-            <a:r>
-              <a:rPr lang="en-US" b="1" dirty="0"/>
-              <a:t>Max-Heap</a:t>
-            </a:r>
-            <a:r>
-              <a:rPr lang="en-US" dirty="0"/>
-              <a:t>: key(parent) ≥ key(children)</a:t>
-            </a:r>
-          </a:p>
-          <a:p>
-            <a:r>
-              <a:rPr lang="en-US" dirty="0"/>
-              <a:t>Implemented as complete binary tree:</a:t>
-            </a:r>
-          </a:p>
-          <a:p>
-            <a:pPr lvl="1"/>
-            <a:r>
-              <a:rPr lang="en-US" dirty="0"/>
-              <a:t>Efficiently stored in an array.</a:t>
-            </a:r>
-          </a:p>
-          <a:p>
-            <a:pPr lvl="1"/>
-            <a:r>
-              <a:rPr lang="en-IN" dirty="0"/>
-              <a:t>Parent(i) = ⌊i/2⌋, Left(i) = 2i, Right(i) = 2i+1</a:t>
-            </a:r>
-            <a:endParaRPr lang="en-US" dirty="0"/>
-          </a:p>
-          <a:p>
-            <a:r>
-              <a:rPr lang="en-US" dirty="0"/>
-              <a:t>Not suitable for binary search but ideal for priority-based scheduling.</a:t>
-            </a:r>
-          </a:p>
-          <a:p>
-            <a:r>
-              <a:rPr lang="en-US" dirty="0"/>
-              <a:t>No ordering among siblings/subtrees — only parent-child relation matters.</a:t>
-            </a:r>
-            <a:endParaRPr lang="en-IN" dirty="0"/>
-          </a:p>
-        </p:txBody>
-      </p:sp>
+          <p:cNvPicPr>
+            <a:picLocks noChangeAspect="1" noChangeArrowheads="1"/>
+          </p:cNvPicPr>
+          <p:nvPr/>
+        </p:nvPicPr>
+        <p:blipFill>
+          <a:blip r:embed="rId2">
+            <a:extLst>
+              <a:ext uri="{28A0092B-C50C-407E-A947-70E740481C1C}">
+                <a14:useLocalDpi xmlns:a14="http://schemas.microsoft.com/office/drawing/2010/main" val="0"/>
+              </a:ext>
+            </a:extLst>
+          </a:blip>
+          <a:srcRect/>
+          <a:stretch>
+            <a:fillRect/>
+          </a:stretch>
+        </p:blipFill>
+        <p:spPr bwMode="auto">
+          <a:xfrm>
+            <a:off x="1473050" y="1853247"/>
+            <a:ext cx="8816377" cy="3607273"/>
+          </a:xfrm>
+          <a:prstGeom prst="rect">
+            <a:avLst/>
+          </a:prstGeom>
+          <a:noFill/>
+          <a:extLst>
+            <a:ext uri="{909E8E84-426E-40DD-AFC4-6F175D3DCCD1}">
+              <a14:hiddenFill xmlns:a14="http://schemas.microsoft.com/office/drawing/2010/main">
+                <a:solidFill>
+                  <a:srgbClr val="FFFFFF"/>
+                </a:solidFill>
+              </a14:hiddenFill>
+            </a:ext>
+          </a:extLst>
+        </p:spPr>
+      </p:pic>
     </p:spTree>
     <p:extLst>
       <p:ext uri="{BB962C8B-B14F-4D97-AF65-F5344CB8AC3E}">
-        <p14:creationId xmlns:p14="http://schemas.microsoft.com/office/powerpoint/2010/main" val="3335179137"/>
+        <p14:creationId xmlns:p14="http://schemas.microsoft.com/office/powerpoint/2010/main" val="2776894370"/>
       </p:ext>
     </p:extLst>
   </p:cSld>
@@ -8779,7 +9101,7 @@
           <p:cNvPr id="2" name="Title 1">
             <a:extLst>
               <a:ext uri="{FF2B5EF4-FFF2-40B4-BE49-F238E27FC236}">
-                <a16:creationId xmlns:a16="http://schemas.microsoft.com/office/drawing/2014/main" id="{EF58C4EA-0BAE-9711-10A3-0090DA183A36}"/>
+                <a16:creationId xmlns:a16="http://schemas.microsoft.com/office/drawing/2014/main" id="{4A25E700-863B-5B39-1E7B-FE12B63574C2}"/>
               </a:ext>
             </a:extLst>
           </p:cNvPr>
@@ -8797,7 +9119,7 @@
           <a:p>
             <a:r>
               <a:rPr lang="en-IN" b="1" dirty="0"/>
-              <a:t>Heap – Deep Dive Theory</a:t>
+              <a:t>Heap – Concepts</a:t>
             </a:r>
             <a:br>
               <a:rPr lang="en-IN" b="1" dirty="0"/>
@@ -8806,310 +9128,94 @@
           </a:p>
         </p:txBody>
       </p:sp>
-      <mc:AlternateContent xmlns:mc="http://schemas.openxmlformats.org/markup-compatibility/2006">
-        <mc:Choice xmlns:a14="http://schemas.microsoft.com/office/drawing/2010/main" Requires="a14">
-          <p:sp>
-            <p:nvSpPr>
-              <p:cNvPr id="3" name="Content Placeholder 2">
-                <a:extLst>
-                  <a:ext uri="{FF2B5EF4-FFF2-40B4-BE49-F238E27FC236}">
-                    <a16:creationId xmlns:a16="http://schemas.microsoft.com/office/drawing/2014/main" id="{FAD27265-03E3-2FE1-D251-028B8CD870F5}"/>
-                  </a:ext>
-                </a:extLst>
-              </p:cNvPr>
-              <p:cNvSpPr>
-                <a:spLocks noGrp="1"/>
-              </p:cNvSpPr>
-              <p:nvPr>
-                <p:ph idx="1"/>
-              </p:nvPr>
-            </p:nvSpPr>
-            <p:spPr/>
-            <p:txBody>
-              <a:bodyPr/>
-              <a:lstStyle/>
-              <a:p>
-                <a:r>
-                  <a:rPr lang="en-IN" dirty="0"/>
-                  <a:t>Insert(x): </a:t>
-                </a:r>
-                <a:r>
-                  <a:rPr lang="en-US" dirty="0"/>
-                  <a:t>Place x at end of array, "bubble up" to maintain heap → O(log n).</a:t>
-                </a:r>
-              </a:p>
-              <a:p>
-                <a:r>
-                  <a:rPr lang="en-IN" dirty="0"/>
-                  <a:t>Extract-Min/Max(): </a:t>
-                </a:r>
-                <a:r>
-                  <a:rPr lang="en-US" dirty="0"/>
-                  <a:t>Remove root, replace with last element, "bubble down" → O(log n).</a:t>
-                </a:r>
-              </a:p>
-              <a:p>
-                <a:r>
-                  <a:rPr lang="en-IN" dirty="0"/>
-                  <a:t>Build-Heap(A):</a:t>
-                </a:r>
-              </a:p>
-              <a:p>
-                <a:pPr lvl="1"/>
-                <a:r>
-                  <a:rPr lang="en-US" dirty="0"/>
-                  <a:t>Convert unordered array into a heap → O(n).</a:t>
-                </a:r>
-              </a:p>
-              <a:p>
-                <a:pPr lvl="1"/>
-                <a:r>
-                  <a:rPr lang="en-IN" dirty="0"/>
-                  <a:t>Done using bottom-up </a:t>
-                </a:r>
-                <a:r>
-                  <a:rPr lang="en-IN" dirty="0" err="1"/>
-                  <a:t>heapify</a:t>
-                </a:r>
-                <a:r>
-                  <a:rPr lang="en-IN" dirty="0"/>
-                  <a:t>:</a:t>
-                </a:r>
-              </a:p>
-              <a:p>
-                <a:pPr lvl="2"/>
-                <a14:m>
-                  <m:oMath xmlns:m="http://schemas.openxmlformats.org/officeDocument/2006/math">
-                    <m:r>
-                      <a:rPr lang="en-IN" i="1" smtClean="0">
-                        <a:latin typeface="Cambria Math" panose="02040503050406030204" pitchFamily="18" charset="0"/>
-                      </a:rPr>
-                      <m:t>𝑇</m:t>
-                    </m:r>
-                    <m:d>
-                      <m:dPr>
-                        <m:ctrlPr>
-                          <a:rPr lang="en-IN" i="1" smtClean="0">
-                            <a:solidFill>
-                              <a:srgbClr val="836967"/>
-                            </a:solidFill>
-                            <a:latin typeface="Cambria Math" panose="02040503050406030204" pitchFamily="18" charset="0"/>
-                          </a:rPr>
-                        </m:ctrlPr>
-                      </m:dPr>
-                      <m:e>
-                        <m:r>
-                          <a:rPr lang="en-IN" i="1" smtClean="0">
-                            <a:latin typeface="Cambria Math" panose="02040503050406030204" pitchFamily="18" charset="0"/>
-                          </a:rPr>
-                          <m:t>𝑁</m:t>
-                        </m:r>
-                      </m:e>
-                    </m:d>
-                    <m:r>
-                      <a:rPr lang="en-IN" i="1" smtClean="0">
-                        <a:latin typeface="Cambria Math" panose="02040503050406030204" pitchFamily="18" charset="0"/>
-                      </a:rPr>
-                      <m:t>=</m:t>
-                    </m:r>
-                    <m:nary>
-                      <m:naryPr>
-                        <m:chr m:val="∑"/>
-                        <m:limLoc m:val="undOvr"/>
-                        <m:grow m:val="on"/>
-                        <m:ctrlPr>
-                          <a:rPr lang="en-IN" i="1" smtClean="0">
-                            <a:latin typeface="Cambria Math" panose="02040503050406030204" pitchFamily="18" charset="0"/>
-                          </a:rPr>
-                        </m:ctrlPr>
-                      </m:naryPr>
-                      <m:sub>
-                        <m:r>
-                          <a:rPr lang="en-IN" i="1" smtClean="0">
-                            <a:latin typeface="Cambria Math" panose="02040503050406030204" pitchFamily="18" charset="0"/>
-                          </a:rPr>
-                          <m:t>𝑖</m:t>
-                        </m:r>
-                        <m:r>
-                          <a:rPr lang="en-IN" i="1" smtClean="0">
-                            <a:latin typeface="Cambria Math" panose="02040503050406030204" pitchFamily="18" charset="0"/>
-                          </a:rPr>
-                          <m:t>=1</m:t>
-                        </m:r>
-                      </m:sub>
-                      <m:sup>
-                        <m:func>
-                          <m:funcPr>
-                            <m:ctrlPr>
-                              <a:rPr lang="en-IN" i="1" smtClean="0">
-                                <a:latin typeface="Cambria Math" panose="02040503050406030204" pitchFamily="18" charset="0"/>
-                              </a:rPr>
-                            </m:ctrlPr>
-                          </m:funcPr>
-                          <m:fName>
-                            <m:r>
-                              <m:rPr>
-                                <m:sty m:val="p"/>
-                              </m:rPr>
-                              <a:rPr lang="en-IN" i="1" smtClean="0">
-                                <a:latin typeface="Cambria Math" panose="02040503050406030204" pitchFamily="18" charset="0"/>
-                              </a:rPr>
-                              <m:t>log</m:t>
-                            </m:r>
-                          </m:fName>
-                          <m:e>
-                            <m:r>
-                              <a:rPr lang="en-IN" i="1" smtClean="0">
-                                <a:latin typeface="Cambria Math" panose="02040503050406030204" pitchFamily="18" charset="0"/>
-                              </a:rPr>
-                              <m:t>𝑁</m:t>
-                            </m:r>
-                          </m:e>
-                        </m:func>
-                      </m:sup>
-                      <m:e>
-                        <m:f>
-                          <m:fPr>
-                            <m:ctrlPr>
-                              <a:rPr lang="en-IN" i="1" smtClean="0">
-                                <a:solidFill>
-                                  <a:srgbClr val="836967"/>
-                                </a:solidFill>
-                                <a:latin typeface="Cambria Math" panose="02040503050406030204" pitchFamily="18" charset="0"/>
-                              </a:rPr>
-                            </m:ctrlPr>
-                          </m:fPr>
-                          <m:num>
-                            <m:r>
-                              <a:rPr lang="en-IN" i="1" smtClean="0">
-                                <a:latin typeface="Cambria Math" panose="02040503050406030204" pitchFamily="18" charset="0"/>
-                              </a:rPr>
-                              <m:t>𝑁</m:t>
-                            </m:r>
-                          </m:num>
-                          <m:den>
-                            <m:sSup>
-                              <m:sSupPr>
-                                <m:ctrlPr>
-                                  <a:rPr lang="en-IN" i="1" smtClean="0">
-                                    <a:solidFill>
-                                      <a:srgbClr val="836967"/>
-                                    </a:solidFill>
-                                    <a:latin typeface="Cambria Math" panose="02040503050406030204" pitchFamily="18" charset="0"/>
-                                  </a:rPr>
-                                </m:ctrlPr>
-                              </m:sSupPr>
-                              <m:e>
-                                <m:r>
-                                  <a:rPr lang="en-IN" i="1" smtClean="0">
-                                    <a:latin typeface="Cambria Math" panose="02040503050406030204" pitchFamily="18" charset="0"/>
-                                  </a:rPr>
-                                  <m:t>2</m:t>
-                                </m:r>
-                              </m:e>
-                              <m:sup>
-                                <m:r>
-                                  <a:rPr lang="en-IN" i="1" smtClean="0">
-                                    <a:latin typeface="Cambria Math" panose="02040503050406030204" pitchFamily="18" charset="0"/>
-                                  </a:rPr>
-                                  <m:t>𝑖</m:t>
-                                </m:r>
-                              </m:sup>
-                            </m:sSup>
-                          </m:den>
-                        </m:f>
-                      </m:e>
-                    </m:nary>
-                    <m:r>
-                      <a:rPr lang="en-IN" i="1" smtClean="0">
-                        <a:latin typeface="Cambria Math" panose="02040503050406030204" pitchFamily="18" charset="0"/>
-                      </a:rPr>
-                      <m:t>⋅ⅈ=</m:t>
-                    </m:r>
-                    <m:r>
-                      <a:rPr lang="en-IN" b="0" i="1" smtClean="0">
-                        <a:latin typeface="Cambria Math" panose="02040503050406030204" pitchFamily="18" charset="0"/>
-                      </a:rPr>
-                      <m:t>𝑂</m:t>
-                    </m:r>
-                    <m:d>
-                      <m:dPr>
-                        <m:ctrlPr>
-                          <a:rPr lang="en-IN" i="1" smtClean="0">
-                            <a:solidFill>
-                              <a:srgbClr val="836967"/>
-                            </a:solidFill>
-                            <a:latin typeface="Cambria Math" panose="02040503050406030204" pitchFamily="18" charset="0"/>
-                          </a:rPr>
-                        </m:ctrlPr>
-                      </m:dPr>
-                      <m:e>
-                        <m:r>
-                          <a:rPr lang="en-IN" i="1" smtClean="0">
-                            <a:latin typeface="Cambria Math" panose="02040503050406030204" pitchFamily="18" charset="0"/>
-                          </a:rPr>
-                          <m:t>𝑁</m:t>
-                        </m:r>
-                      </m:e>
-                    </m:d>
-                  </m:oMath>
-                </a14:m>
-                <a:endParaRPr lang="en-IN" dirty="0"/>
-              </a:p>
-              <a:p>
-                <a:r>
-                  <a:rPr lang="en-US" dirty="0"/>
-                  <a:t>Heap is not BST: No search guarantees or in-order traversal.</a:t>
-                </a:r>
-                <a:endParaRPr lang="en-IN" dirty="0"/>
-              </a:p>
-            </p:txBody>
-          </p:sp>
-        </mc:Choice>
-        <mc:Fallback>
-          <p:sp>
-            <p:nvSpPr>
-              <p:cNvPr id="3" name="Content Placeholder 2">
-                <a:extLst>
-                  <a:ext uri="{FF2B5EF4-FFF2-40B4-BE49-F238E27FC236}">
-                    <a16:creationId xmlns:a16="http://schemas.microsoft.com/office/drawing/2014/main" id="{FAD27265-03E3-2FE1-D251-028B8CD870F5}"/>
-                  </a:ext>
-                </a:extLst>
-              </p:cNvPr>
-              <p:cNvSpPr>
-                <a:spLocks noGrp="1" noRot="1" noChangeAspect="1" noMove="1" noResize="1" noEditPoints="1" noAdjustHandles="1" noChangeArrowheads="1" noChangeShapeType="1" noTextEdit="1"/>
-              </p:cNvSpPr>
-              <p:nvPr>
-                <p:ph idx="1"/>
-              </p:nvPr>
-            </p:nvSpPr>
-            <p:spPr>
-              <a:blipFill>
-                <a:blip r:embed="rId2"/>
-                <a:stretch>
-                  <a:fillRect l="-341" t="-872"/>
-                </a:stretch>
-              </a:blipFill>
-            </p:spPr>
-            <p:txBody>
-              <a:bodyPr/>
-              <a:lstStyle/>
-              <a:p>
-                <a:r>
-                  <a:rPr lang="en-IN">
-                    <a:noFill/>
-                  </a:rPr>
-                  <a:t> </a:t>
-                </a:r>
-              </a:p>
-            </p:txBody>
-          </p:sp>
-        </mc:Fallback>
-      </mc:AlternateContent>
+      <p:sp>
+        <p:nvSpPr>
+          <p:cNvPr id="3" name="Content Placeholder 2">
+            <a:extLst>
+              <a:ext uri="{FF2B5EF4-FFF2-40B4-BE49-F238E27FC236}">
+                <a16:creationId xmlns:a16="http://schemas.microsoft.com/office/drawing/2014/main" id="{F8C21B42-A14A-5CD2-C7F3-3EF26A323FF0}"/>
+              </a:ext>
+            </a:extLst>
+          </p:cNvPr>
+          <p:cNvSpPr>
+            <a:spLocks noGrp="1"/>
+          </p:cNvSpPr>
+          <p:nvPr>
+            <p:ph idx="1"/>
+          </p:nvPr>
+        </p:nvSpPr>
+        <p:spPr/>
+        <p:txBody>
+          <a:bodyPr/>
+          <a:lstStyle/>
+          <a:p>
+            <a:r>
+              <a:rPr lang="en-US" dirty="0"/>
+              <a:t>A heap is a binary tree where each node satisfies the heap-order property:</a:t>
+            </a:r>
+          </a:p>
+          <a:p>
+            <a:pPr lvl="1"/>
+            <a:r>
+              <a:rPr lang="en-US" b="1" dirty="0"/>
+              <a:t>Min-Heap</a:t>
+            </a:r>
+            <a:r>
+              <a:rPr lang="en-US" dirty="0"/>
+              <a:t>: key(parent) ≤ key(children)</a:t>
+            </a:r>
+          </a:p>
+          <a:p>
+            <a:pPr lvl="1"/>
+            <a:r>
+              <a:rPr lang="en-US" b="1" dirty="0"/>
+              <a:t>Max-Heap</a:t>
+            </a:r>
+            <a:r>
+              <a:rPr lang="en-US" dirty="0"/>
+              <a:t>: key(parent) ≥ key(children)</a:t>
+            </a:r>
+          </a:p>
+          <a:p>
+            <a:r>
+              <a:rPr lang="en-US" dirty="0"/>
+              <a:t>Implemented as complete binary tree:</a:t>
+            </a:r>
+          </a:p>
+          <a:p>
+            <a:pPr lvl="1"/>
+            <a:r>
+              <a:rPr lang="en-US" dirty="0"/>
+              <a:t>Efficiently stored in an array.</a:t>
+            </a:r>
+          </a:p>
+          <a:p>
+            <a:pPr lvl="1"/>
+            <a:r>
+              <a:rPr lang="en-IN" dirty="0"/>
+              <a:t>Parent(i) = ⌊i/2⌋, Left(i) = 2i, Right(i) = 2i+1</a:t>
+            </a:r>
+            <a:endParaRPr lang="en-US" dirty="0"/>
+          </a:p>
+          <a:p>
+            <a:r>
+              <a:rPr lang="en-US" dirty="0"/>
+              <a:t>Not suitable for binary search but ideal for priority-based scheduling.</a:t>
+            </a:r>
+          </a:p>
+          <a:p>
+            <a:r>
+              <a:rPr lang="en-US" dirty="0"/>
+              <a:t>No ordering among siblings/subtrees — only parent-child relation matters.</a:t>
+            </a:r>
+            <a:endParaRPr lang="en-IN" dirty="0"/>
+          </a:p>
+        </p:txBody>
+      </p:sp>
     </p:spTree>
     <p:extLst>
       <p:ext uri="{BB962C8B-B14F-4D97-AF65-F5344CB8AC3E}">
-        <p14:creationId xmlns:p14="http://schemas.microsoft.com/office/powerpoint/2010/main" val="4014647038"/>
+        <p14:creationId xmlns:p14="http://schemas.microsoft.com/office/powerpoint/2010/main" val="3335179137"/>
       </p:ext>
     </p:extLst>
   </p:cSld>

</xml_diff>